<commit_message>
Clarify widget concept in KT1 slides and speech
</commit_message>
<xml_diff>
--- a/docs/lab-01/Презентация_GoCue_КТ1.pptx
+++ b/docs/lab-01/Презентация_GoCue_КТ1.pptx
@@ -6849,6 +6849,119 @@
                 <a:latin typeface="Arial"/>
               </a:rPr>
               <a:t>Завершить дело или отложить до следующего визита.</a:t>
+            </a:r>
+          </a:p>
+        </p:txBody>
+      </p:sp>
+      <p:sp>
+        <p:nvSpPr>
+          <p:cNvPr id="27" name="Rounded Rectangle 26"/>
+          <p:cNvSpPr/>
+          <p:nvPr/>
+        </p:nvSpPr>
+        <p:spPr>
+          <a:xfrm>
+            <a:off x="5715000" y="5596128"/>
+            <a:ext cx="5650992" cy="530352"/>
+          </a:xfrm>
+          <a:prstGeom prst="roundRect">
+            <a:avLst>
+              <a:gd name="adj" fmla="val 12000"/>
+            </a:avLst>
+          </a:prstGeom>
+          <a:solidFill>
+            <a:srgbClr val="E2EEF8"/>
+          </a:solidFill>
+          <a:ln>
+            <a:noFill/>
+          </a:ln>
+        </p:spPr>
+        <p:style>
+          <a:lnRef idx="1">
+            <a:schemeClr val="accent1"/>
+          </a:lnRef>
+          <a:fillRef idx="3">
+            <a:schemeClr val="accent1"/>
+          </a:fillRef>
+          <a:effectRef idx="2">
+            <a:schemeClr val="accent1"/>
+          </a:effectRef>
+          <a:fontRef idx="minor">
+            <a:schemeClr val="lt1"/>
+          </a:fontRef>
+        </p:style>
+        <p:txBody>
+          <a:bodyPr rtlCol="0" anchor="ctr"/>
+          <a:lstStyle/>
+          <a:p>
+            <a:pPr algn="ctr"/>
+          </a:p>
+        </p:txBody>
+      </p:sp>
+      <p:sp>
+        <p:nvSpPr>
+          <p:cNvPr id="28" name="TextBox 27"/>
+          <p:cNvSpPr txBox="1"/>
+          <p:nvPr/>
+        </p:nvSpPr>
+        <p:spPr>
+          <a:xfrm>
+            <a:off x="5916168" y="5696712"/>
+            <a:ext cx="841248" cy="274320"/>
+          </a:xfrm>
+          <a:prstGeom prst="rect">
+            <a:avLst/>
+          </a:prstGeom>
+          <a:noFill/>
+        </p:spPr>
+        <p:txBody>
+          <a:bodyPr wrap="square" lIns="0" rIns="0" tIns="0" bIns="0" anchor="ctr">
+            <a:spAutoFit/>
+          </a:bodyPr>
+          <a:lstStyle/>
+          <a:p>
+            <a:r>
+              <a:rPr sz="1100" b="1">
+                <a:solidFill>
+                  <a:srgbClr val="2B71B2"/>
+                </a:solidFill>
+                <a:latin typeface="Arial"/>
+              </a:rPr>
+              <a:t>Виджет</a:t>
+            </a:r>
+          </a:p>
+        </p:txBody>
+      </p:sp>
+      <p:sp>
+        <p:nvSpPr>
+          <p:cNvPr id="29" name="TextBox 28"/>
+          <p:cNvSpPr txBox="1"/>
+          <p:nvPr/>
+        </p:nvSpPr>
+        <p:spPr>
+          <a:xfrm>
+            <a:off x="6821424" y="5641848"/>
+            <a:ext cx="4233672" cy="429768"/>
+          </a:xfrm>
+          <a:prstGeom prst="rect">
+            <a:avLst/>
+          </a:prstGeom>
+          <a:noFill/>
+        </p:spPr>
+        <p:txBody>
+          <a:bodyPr wrap="square" lIns="0" rIns="0" tIns="0" bIns="0" anchor="ctr">
+            <a:spAutoFit/>
+          </a:bodyPr>
+          <a:lstStyle/>
+          <a:p>
+            <a:r>
+              <a:rPr sz="1050" b="0">
+                <a:solidFill>
+                  <a:srgbClr val="203041"/>
+                </a:solidFill>
+                <a:latin typeface="Arial"/>
+              </a:rPr>
+              <a:t>Список на главном экране; сам не всплывает — при визите нужно уведомление.</a:t>
             </a:r>
           </a:p>
         </p:txBody>

</xml_diff>